<commit_message>
Add AUC/CV formula explanation and out-of-fold ROC curve as verifiable proof
- train_model.py now exports out-of-fold predictions via cross_val_predict
  and saves the resulting ROC curve (fpr/tpr) to model/roc_curve.csv
- Dashboard model insight tab shows the AUC and 5-fold CV formulas plus
  a real ROC curve plotted from those out-of-fold predictions
- Updated slide deck's technical validation slide with the same evidence
</commit_message>
<xml_diff>
--- a/docs/中化智匯盃_簡報.pptx
+++ b/docs/中化智匯盃_簡報.pptx
@@ -3526,12 +3526,12 @@
         </p:nvSpPr>
         <p:spPr>
           <a:xfrm>
-            <a:off x="585216" y="1636776"/>
-            <a:ext cx="5504688" cy="3346704"/>
+            <a:off x="585216" y="1499616"/>
+            <a:ext cx="6114743" cy="4133088"/>
           </a:xfrm>
           <a:prstGeom prst="roundRect">
             <a:avLst>
-              <a:gd name="adj" fmla="val 1639"/>
+              <a:gd name="adj" fmla="val 1327"/>
             </a:avLst>
           </a:prstGeom>
           <a:solidFill>
@@ -3547,7 +3547,7 @@
       </p:sp>
       <p:pic>
         <p:nvPicPr>
-          <p:cNvPr id="5" name="Image 0" descr="C:\Users\sherr\Desktop\智慧巡訪與成交預判系統\docs\screenshots\crop\cv_chart.png">    </p:cNvPr>
+          <p:cNvPr id="5" name="Image 0" descr="C:\Users\sherr\Desktop\智慧巡訪與成交預判系統\docs\screenshots\crop\roc_formula.png">    </p:cNvPr>
           <p:cNvPicPr>
             <a:picLocks noChangeAspect="1"/>
           </p:cNvPicPr>
@@ -3561,8 +3561,8 @@
         </p:blipFill>
         <p:spPr>
           <a:xfrm>
-            <a:off x="640080" y="1691640"/>
-            <a:ext cx="5394960" cy="3236976"/>
+            <a:off x="640080" y="1554480"/>
+            <a:ext cx="6005015" cy="4023360"/>
           </a:xfrm>
           <a:prstGeom prst="rect">
             <a:avLst/>
@@ -3577,8 +3577,8 @@
         </p:nvSpPr>
         <p:spPr>
           <a:xfrm>
-            <a:off x="640080" y="5001768"/>
-            <a:ext cx="5394960" cy="292608"/>
+            <a:off x="640080" y="5650992"/>
+            <a:ext cx="6492240" cy="292608"/>
           </a:xfrm>
           <a:prstGeom prst="rect">
             <a:avLst/>
@@ -3602,7 +3602,7 @@
                 <a:ea typeface="Microsoft JhengHei" pitchFamily="34" charset="-122"/>
                 <a:cs typeface="Microsoft JhengHei" pitchFamily="34" charset="-120"/>
               </a:rPr>
-              <a:t>實際畫面：5-fold 交叉驗證 AUC 0.618 ± 0.023</a:t>
+              <a:t>實際畫面：AUC／交叉驗證公式 ＋ out-of-fold ROC 曲線（可用 model/roc_curve.csv 重算驗證）</a:t>
             </a:r>
             <a:endParaRPr lang="en-US" sz="1100" dirty="0"/>
           </a:p>
@@ -3616,12 +3616,12 @@
         </p:nvSpPr>
         <p:spPr>
           <a:xfrm>
-            <a:off x="6117336" y="1636776"/>
-            <a:ext cx="5504688" cy="1944014"/>
+            <a:off x="7306056" y="1499616"/>
+            <a:ext cx="4270248" cy="1524305"/>
           </a:xfrm>
           <a:prstGeom prst="roundRect">
             <a:avLst>
-              <a:gd name="adj" fmla="val 2822"/>
+              <a:gd name="adj" fmla="val 3599"/>
             </a:avLst>
           </a:prstGeom>
           <a:solidFill>
@@ -3651,8 +3651,8 @@
         </p:blipFill>
         <p:spPr>
           <a:xfrm>
-            <a:off x="6172200" y="1691640"/>
-            <a:ext cx="5394960" cy="1834286"/>
+            <a:off x="7360920" y="1554480"/>
+            <a:ext cx="4160520" cy="1414577"/>
           </a:xfrm>
           <a:prstGeom prst="rect">
             <a:avLst/>
@@ -3667,8 +3667,8 @@
         </p:nvSpPr>
         <p:spPr>
           <a:xfrm>
-            <a:off x="6172200" y="3599078"/>
-            <a:ext cx="5394960" cy="292608"/>
+            <a:off x="7360920" y="3042209"/>
+            <a:ext cx="4160520" cy="292608"/>
           </a:xfrm>
           <a:prstGeom prst="rect">
             <a:avLst/>

</xml_diff>